<commit_message>
update to simpler language
</commit_message>
<xml_diff>
--- a/slides/ARC3133_Class06.pptx
+++ b/slides/ARC3133_Class06.pptx
@@ -6301,7 +6301,7 @@
                 </a:solidFill>
                 <a:latin typeface="Calibri"/>
               </a:rPr>
-              <a:t>1D: build a small linear array with Repeat Input and Repeat Output. Identify list, count and index.</a:t>
+              <a:t>1D: build a small row with Repeat Input and Repeat Output. Find the list, the count and the index.</a:t>
             </a:r>
           </a:p>
         </p:txBody>
@@ -6551,7 +6551,7 @@
                 </a:solidFill>
                 <a:latin typeface="Calibri"/>
               </a:rPr>
-              <a:t>2D: nest repetition into a grid. Identify rows and columns; predict the total count.</a:t>
+              <a:t>2D: put the row inside a second loop to make a grid. Name the rows and columns, and predict the total count.</a:t>
             </a:r>
           </a:p>
         </p:txBody>
@@ -6801,7 +6801,7 @@
                 </a:solidFill>
                 <a:latin typeface="Calibri"/>
               </a:rPr>
-              <a:t>3D: repeat the grid in Z for a cube array. Predict Count cubed; distinguish instances from a sampled volume.</a:t>
+              <a:t>3D: stack the grid in layers to make a cube of copies. Before you look, predict how many there are (Count × Count × Count). These are separate copies of one object, not a solid block.</a:t>
             </a:r>
           </a:p>
         </p:txBody>
@@ -7051,7 +7051,7 @@
                 </a:solidFill>
                 <a:latin typeface="Calibri"/>
               </a:rPr>
-              <a:t>Curve: bend the row. Sample a curve at even spacing and place your module at each point, turned to follow the curve's direction. The count comes from curve length ÷ spacing.</a:t>
+              <a:t>Curve: bend the row. Place your module at evenly spaced points along a curve, each turned to follow the curve's direction. The count is the curve's length ÷ the spacing.</a:t>
             </a:r>
           </a:p>
         </p:txBody>
@@ -7191,7 +7191,7 @@
                 </a:solidFill>
                 <a:latin typeface="Calibri"/>
               </a:rPr>
-              <a:t>Check geometry, units, orientation and the sliced preview before queueing.</a:t>
+              <a:t>Before you queue the print, check the geometry, units, orientation and sliced preview.</a:t>
             </a:r>
           </a:p>
         </p:txBody>
@@ -10095,7 +10095,7 @@
                 </a:solidFill>
                 <a:latin typeface="Calibri"/>
               </a:rPr>
-              <a:t>Sheet 1 — four diagrams: your 3.1 module alone, your module in a 1D array, your module in a 2D array, and your module in a 3D array. Use the same module and label counts, spacing and axes.</a:t>
+              <a:t>Sheet 1 — four diagrams: your 3.1 module alone, then in a 1D, a 2D and a 3D array. Use the same module throughout, and label the counts, spacing and axes.</a:t>
             </a:r>
           </a:p>
         </p:txBody>
@@ -10345,7 +10345,7 @@
                 </a:solidFill>
                 <a:latin typeface="Calibri"/>
               </a:rPr>
-              <a:t>Sheet 2 — four façade-pattern diagrams: use your module in a 2D array and if/Switch conditions to generate four different patterns. Each diagram must identify its condition and resulting modification.</a:t>
+              <a:t>Sheet 2 — four façade-pattern diagrams: apply if/Switch rules to a 2D array of your module to make four different patterns. Each diagram names its rule and what it changes.</a:t>
             </a:r>
           </a:p>
         </p:txBody>
@@ -10595,7 +10595,7 @@
                 </a:solidFill>
                 <a:latin typeface="Calibri"/>
               </a:rPr>
-              <a:t>Sheet 3 — volumetric exploration: use cubes in a 3D array and present an isometric view. Drive vertical variation with a mathematical function of both X and Y, such as sine or cosine. Explore the resulting spatial form; optionally combine it with Switch conditions to generate voids.</a:t>
+              <a:t>Sheet 3 — a volume of cubes: make a 3D array of cubes and show it in isometric. Change the height of the cubes with a math function of both X and Y, such as sine or cosine, and explore the form it creates. Optionally, use Switch rules to make voids.</a:t>
             </a:r>
           </a:p>
         </p:txBody>
@@ -10845,7 +10845,7 @@
                 </a:solidFill>
                 <a:latin typeface="Calibri"/>
               </a:rPr>
-              <a:t>Reuse the 3.1 panel definition on Sheets 1–2. Sheet 2 may transform or omit selected instances to make a pattern. Use cubes, rather than the panel, for the volumetric exercise on Sheet 3.</a:t>
+              <a:t>Reuse the 3.1 panel on Sheets 1–2. On Sheet 2 you may change or remove selected copies to make a pattern. Use cubes, not the panel, on Sheet 3.</a:t>
             </a:r>
           </a:p>
         </p:txBody>
@@ -11095,7 +11095,7 @@
                 </a:solidFill>
                 <a:latin typeface="Calibri"/>
               </a:rPr>
-              <a:t>Present simple diagrams using one consistent view and material for comparable studies. Keep lighting consistent; separate polished render setups for the four façade patterns are not required. Choose an appropriate view for each dimensional array and use isometric for the cube volume.</a:t>
+              <a:t>Keep the diagrams simple, with the same view and material wherever studies are compared. Keep the lighting consistent; the four façade patterns don't need separate polished renders. Choose a suitable view for each array, and use isometric for the cube volume.</a:t>
             </a:r>
           </a:p>
         </p:txBody>
@@ -11345,7 +11345,7 @@
                 </a:solidFill>
                 <a:latin typeface="Calibri"/>
               </a:rPr>
-              <a:t>Build repetition from basic nodes and begin with a count you can inspect; there is no minimum element count.</a:t>
+              <a:t>Build the repetition from basic nodes, starting with a count small enough to check by eye; there is no minimum number of copies.</a:t>
             </a:r>
           </a:p>
         </p:txBody>
@@ -11595,7 +11595,7 @@
                 </a:solidFill>
                 <a:latin typeface="Calibri"/>
               </a:rPr>
-              <a:t>Use materials from the instructor-provided library or create your own. Record which materials you used and any edits; package required textures. Material choice must keep array spacing, depth and repetition readable. The library will be posted before this assignment is due; creating your own remains an equally valid route.</a:t>
+              <a:t>Use materials from the library the instructors provide, or make your own. Note which materials you used and any changes; pack any textures. Materials must keep the spacing, depth and repetition of the array readable. The library will be posted before this assignment is due; making your own is equally fine.</a:t>
             </a:r>
           </a:p>
         </p:txBody>

</xml_diff>